<commit_message>
docs: align Caltech results across materials
</commit_message>
<xml_diff>
--- a/projects/face_detection_course_defense_cn_ppt169_20260526/exports/PPT.pptx
+++ b/projects/face_detection_course_defense_cn_ppt169_20260526/exports/PPT.pptx
@@ -18223,7 +18223,7 @@
             <a:p>
               <a:pPr algn="l"/>
               <a:r>
-                <a:rPr lang="zh-CN" sz="1500" b="1" dirty="0">
+                <a:rPr lang="zh-CN" sz="1500" b="1">
                   <a:solidFill>
                     <a:srgbClr val="16324F"/>
                   </a:solidFill>
@@ -18231,8 +18231,16 @@
                   <a:ea typeface="Microsoft YaHei"/>
                   <a:cs typeface="Arial"/>
                 </a:rPr>
-                <a:t>答辩要点</a:t>
+                <a:t>要点</a:t>
               </a:r>
+              <a:endParaRPr lang="zh-CN" sz="1500" b="1" dirty="0">
+                <a:solidFill>
+                  <a:srgbClr val="16324F"/>
+                </a:solidFill>
+                <a:latin typeface="Arial"/>
+                <a:ea typeface="Microsoft YaHei"/>
+                <a:cs typeface="Arial"/>
+              </a:endParaRPr>
             </a:p>
           </p:txBody>
         </p:sp>
@@ -21291,7 +21299,7 @@
                   <a:ea typeface="Microsoft YaHei"/>
                   <a:cs typeface="Arial"/>
                 </a:rPr>
-                <a:t>Caltech：OpenCV F1=0.759，自实现 v3 F1=0.553</a:t>
+                <a:t>Caltech：OpenCV F1=0.824，自实现 v6.1 F1=0.619</a:t>
               </a:r>
             </a:p>
           </p:txBody>

</xml_diff>